<commit_message>
Removed wrong presentation files
</commit_message>
<xml_diff>
--- a/docs/Presentation.pptx
+++ b/docs/Presentation.pptx
@@ -122,6 +122,7 @@
 <p1510:revInfo xmlns:a="http://schemas.openxmlformats.org/drawingml/2006/main" xmlns:r="http://schemas.openxmlformats.org/officeDocument/2006/relationships" xmlns:p1510="http://schemas.microsoft.com/office/powerpoint/2015/10/main">
   <p1510:revLst>
     <p1510:client id="{5C444C5E-7A32-4573-8A9D-FB5B921722D5}" v="58" dt="2026-10-11T16:23:24.152"/>
+    <p1510:client id="{CBF3EAB4-98BC-425E-B3E3-C0C0E6D4D287}" v="125" dt="2026-10-11T17:20:47.950"/>
   </p1510:revLst>
 </p1510:revInfo>
 </file>
@@ -6512,6 +6513,148 @@
           </a:p>
         </p:txBody>
       </p:sp>
+      <p:sp>
+        <p:nvSpPr>
+          <p:cNvPr id="16" name="TextBox 15">
+            <a:extLst>
+              <a:ext uri="{FF2B5EF4-FFF2-40B4-BE49-F238E27FC236}">
+                <a16:creationId xmlns:a16="http://schemas.microsoft.com/office/drawing/2014/main" id="{5D7B6A3A-EF31-FD12-A334-BB8C99C1ACA8}"/>
+              </a:ext>
+            </a:extLst>
+          </p:cNvPr>
+          <p:cNvSpPr txBox="1"/>
+          <p:nvPr/>
+        </p:nvSpPr>
+        <p:spPr>
+          <a:xfrm>
+            <a:off x="10259060" y="5935980"/>
+            <a:ext cx="942340" cy="246221"/>
+          </a:xfrm>
+          <a:prstGeom prst="rect">
+            <a:avLst/>
+          </a:prstGeom>
+          <a:solidFill>
+            <a:srgbClr val="FFFFFF"/>
+          </a:solidFill>
+        </p:spPr>
+        <p:txBody>
+          <a:bodyPr rot="0" spcFirstLastPara="0" vertOverflow="overflow" horzOverflow="overflow" vert="horz" wrap="square" lIns="91440" tIns="45720" rIns="91440" bIns="45720" numCol="1" spcCol="0" rtlCol="0" fromWordArt="0" anchor="t" anchorCtr="0" forceAA="0" compatLnSpc="1">
+            <a:prstTxWarp prst="textNoShape">
+              <a:avLst/>
+            </a:prstTxWarp>
+            <a:spAutoFit/>
+          </a:bodyPr>
+          <a:lstStyle/>
+          <a:p>
+            <a:pPr algn="l"/>
+            <a:r>
+              <a:rPr lang="en-US" sz="1000">
+                <a:latin typeface="Calibri Light"/>
+                <a:ea typeface="Calibri Light"/>
+                <a:cs typeface="Calibri Light"/>
+              </a:rPr>
+              <a:t>Foreshock</a:t>
+            </a:r>
+          </a:p>
+        </p:txBody>
+      </p:sp>
+      <p:sp>
+        <p:nvSpPr>
+          <p:cNvPr id="18" name="TextBox 17">
+            <a:extLst>
+              <a:ext uri="{FF2B5EF4-FFF2-40B4-BE49-F238E27FC236}">
+                <a16:creationId xmlns:a16="http://schemas.microsoft.com/office/drawing/2014/main" id="{06E234B1-D10B-8062-0AF1-12EB9887FDCE}"/>
+              </a:ext>
+            </a:extLst>
+          </p:cNvPr>
+          <p:cNvSpPr txBox="1"/>
+          <p:nvPr/>
+        </p:nvSpPr>
+        <p:spPr>
+          <a:xfrm>
+            <a:off x="3048000" y="3429000"/>
+            <a:ext cx="6096000" cy="523220"/>
+          </a:xfrm>
+          <a:prstGeom prst="rect">
+            <a:avLst/>
+          </a:prstGeom>
+          <a:noFill/>
+        </p:spPr>
+        <p:txBody>
+          <a:bodyPr rot="0" spcFirstLastPara="0" vertOverflow="overflow" horzOverflow="overflow" vert="horz" wrap="square" lIns="91440" tIns="45720" rIns="91440" bIns="45720" numCol="1" spcCol="0" rtlCol="0" fromWordArt="0" anchor="t" anchorCtr="0" forceAA="0" compatLnSpc="1">
+            <a:prstTxWarp prst="textNoShape">
+              <a:avLst/>
+            </a:prstTxWarp>
+            <a:spAutoFit/>
+          </a:bodyPr>
+          <a:lstStyle/>
+          <a:p>
+            <a:r>
+              <a:rPr lang="en-US" sz="1000" b="0" i="0" u="none" strike="noStrike" baseline="0">
+                <a:solidFill>
+                  <a:srgbClr val="000000"/>
+                </a:solidFill>
+                <a:latin typeface="Calibri Light"/>
+              </a:rPr>
+              <a:t>Foreshock</a:t>
+            </a:r>
+            <a:endParaRPr lang="en-US"/>
+          </a:p>
+          <a:p>
+            <a:pPr algn="ctr"/>
+            <a:endParaRPr lang="en-US"/>
+          </a:p>
+        </p:txBody>
+      </p:sp>
+      <p:sp>
+        <p:nvSpPr>
+          <p:cNvPr id="19" name="TextBox 18">
+            <a:extLst>
+              <a:ext uri="{FF2B5EF4-FFF2-40B4-BE49-F238E27FC236}">
+                <a16:creationId xmlns:a16="http://schemas.microsoft.com/office/drawing/2014/main" id="{021E66AF-0A36-7E10-1826-9B69452D9FB4}"/>
+              </a:ext>
+            </a:extLst>
+          </p:cNvPr>
+          <p:cNvSpPr txBox="1"/>
+          <p:nvPr/>
+        </p:nvSpPr>
+        <p:spPr>
+          <a:xfrm>
+            <a:off x="8399780" y="5935979"/>
+            <a:ext cx="1562100" cy="246221"/>
+          </a:xfrm>
+          <a:prstGeom prst="rect">
+            <a:avLst/>
+          </a:prstGeom>
+          <a:solidFill>
+            <a:srgbClr val="FFFFFF"/>
+          </a:solidFill>
+        </p:spPr>
+        <p:txBody>
+          <a:bodyPr rot="0" spcFirstLastPara="0" vertOverflow="overflow" horzOverflow="overflow" vert="horz" wrap="square" lIns="91440" tIns="45720" rIns="91440" bIns="45720" numCol="1" spcCol="0" rtlCol="0" fromWordArt="0" anchor="t" anchorCtr="0" forceAA="0" compatLnSpc="1">
+            <a:prstTxWarp prst="textNoShape">
+              <a:avLst/>
+            </a:prstTxWarp>
+            <a:spAutoFit/>
+          </a:bodyPr>
+          <a:lstStyle/>
+          <a:p>
+            <a:r>
+              <a:rPr lang="en-US" sz="1000">
+                <a:latin typeface="Calibri Light"/>
+                <a:ea typeface="Calibri Light"/>
+                <a:cs typeface="Calibri Light"/>
+              </a:rPr>
+              <a:t>Naïve sentiment weights</a:t>
+            </a:r>
+            <a:endParaRPr lang="en-US" sz="1000" dirty="0">
+              <a:latin typeface="Calibri Light"/>
+              <a:ea typeface="Calibri Light"/>
+              <a:cs typeface="Calibri Light"/>
+            </a:endParaRPr>
+          </a:p>
+        </p:txBody>
+      </p:sp>
     </p:spTree>
   </p:cSld>
   <p:clrMapOvr>
@@ -7882,13 +8025,13 @@
       </p:sp>
       <p:sp>
         <p:nvSpPr>
-          <p:cNvPr id="8" name="Shape 5"/>
+          <p:cNvPr id="11" name="Shape 8"/>
           <p:cNvSpPr/>
           <p:nvPr/>
         </p:nvSpPr>
         <p:spPr>
           <a:xfrm>
-            <a:off x="6400800" y="2048256"/>
+            <a:off x="6350000" y="2137664"/>
             <a:ext cx="457200" cy="457200"/>
           </a:xfrm>
           <a:prstGeom prst="ellipse">
@@ -7907,13 +8050,13 @@
       </p:sp>
       <p:sp>
         <p:nvSpPr>
-          <p:cNvPr id="9" name="Text 6"/>
-          <p:cNvSpPr txBox="1"/>
-          <p:nvPr/>
-        </p:nvSpPr>
-        <p:spPr>
-          <a:xfrm>
-            <a:off x="6400800" y="2048256"/>
+          <p:cNvPr id="12" name="Text 9"/>
+          <p:cNvSpPr txBox="1"/>
+          <p:nvPr/>
+        </p:nvSpPr>
+        <p:spPr>
+          <a:xfrm>
+            <a:off x="6350000" y="2137664"/>
             <a:ext cx="457200" cy="457200"/>
           </a:xfrm>
           <a:prstGeom prst="rect">
@@ -7930,29 +8073,27 @@
               <a:buNone/>
             </a:pPr>
             <a:r>
-              <a:rPr lang="en-US" sz="1700" b="1" dirty="0">
+              <a:rPr lang="en-US" sz="1700" b="1">
                 <a:solidFill>
                   <a:srgbClr val="FFFFFF"/>
                 </a:solidFill>
-                <a:latin typeface="Cambria" pitchFamily="34" charset="0"/>
-                <a:ea typeface="Cambria" pitchFamily="34" charset="-122"/>
-                <a:cs typeface="Cambria" pitchFamily="34" charset="-120"/>
+                <a:latin typeface="Cambria"/>
+                <a:ea typeface="Cambria"/>
               </a:rPr>
               <a:t>1</a:t>
             </a:r>
-            <a:endParaRPr lang="en-US" sz="1700" dirty="0"/>
-          </a:p>
-        </p:txBody>
-      </p:sp>
-      <p:sp>
-        <p:nvSpPr>
-          <p:cNvPr id="10" name="Text 7"/>
-          <p:cNvSpPr txBox="1"/>
-          <p:nvPr/>
-        </p:nvSpPr>
-        <p:spPr>
-          <a:xfrm>
-            <a:off x="7040880" y="2011680"/>
+          </a:p>
+        </p:txBody>
+      </p:sp>
+      <p:sp>
+        <p:nvSpPr>
+          <p:cNvPr id="13" name="Text 10"/>
+          <p:cNvSpPr txBox="1"/>
+          <p:nvPr/>
+        </p:nvSpPr>
+        <p:spPr>
+          <a:xfrm>
+            <a:off x="6990080" y="2101088"/>
             <a:ext cx="4572000" cy="868680"/>
           </a:xfrm>
           <a:prstGeom prst="rect">
@@ -7977,7 +8118,7 @@
                 <a:ea typeface="Calibri" pitchFamily="34" charset="-122"/>
                 <a:cs typeface="Calibri" pitchFamily="34" charset="-120"/>
               </a:rPr>
-              <a:t>Fine-tune FinBERT and an event classifier on Kaggle and GDELT labels; the backend flag already exists.</a:t>
+              <a:t>Calibrate impact with event studies on real returns instead of a hand-tuned scale.</a:t>
             </a:r>
             <a:endParaRPr lang="en-US" sz="1500" dirty="0"/>
           </a:p>
@@ -7985,13 +8126,13 @@
       </p:sp>
       <p:sp>
         <p:nvSpPr>
-          <p:cNvPr id="11" name="Shape 8"/>
+          <p:cNvPr id="14" name="Shape 11"/>
           <p:cNvSpPr/>
           <p:nvPr/>
         </p:nvSpPr>
         <p:spPr>
           <a:xfrm>
-            <a:off x="6400800" y="3072384"/>
+            <a:off x="6350000" y="3161792"/>
             <a:ext cx="457200" cy="457200"/>
           </a:xfrm>
           <a:prstGeom prst="ellipse">
@@ -8010,13 +8151,13 @@
       </p:sp>
       <p:sp>
         <p:nvSpPr>
-          <p:cNvPr id="12" name="Text 9"/>
-          <p:cNvSpPr txBox="1"/>
-          <p:nvPr/>
-        </p:nvSpPr>
-        <p:spPr>
-          <a:xfrm>
-            <a:off x="6400800" y="3072384"/>
+          <p:cNvPr id="15" name="Text 12"/>
+          <p:cNvSpPr txBox="1"/>
+          <p:nvPr/>
+        </p:nvSpPr>
+        <p:spPr>
+          <a:xfrm>
+            <a:off x="6350000" y="3161792"/>
             <a:ext cx="457200" cy="457200"/>
           </a:xfrm>
           <a:prstGeom prst="rect">
@@ -8033,29 +8174,27 @@
               <a:buNone/>
             </a:pPr>
             <a:r>
-              <a:rPr lang="en-US" sz="1700" b="1" dirty="0">
+              <a:rPr lang="en-US" sz="1700" b="1">
                 <a:solidFill>
                   <a:srgbClr val="FFFFFF"/>
                 </a:solidFill>
-                <a:latin typeface="Cambria" pitchFamily="34" charset="0"/>
-                <a:ea typeface="Cambria" pitchFamily="34" charset="-122"/>
-                <a:cs typeface="Cambria" pitchFamily="34" charset="-120"/>
+                <a:latin typeface="Cambria"/>
+                <a:ea typeface="Cambria"/>
               </a:rPr>
               <a:t>2</a:t>
             </a:r>
-            <a:endParaRPr lang="en-US" sz="1700" dirty="0"/>
-          </a:p>
-        </p:txBody>
-      </p:sp>
-      <p:sp>
-        <p:nvSpPr>
-          <p:cNvPr id="13" name="Text 10"/>
-          <p:cNvSpPr txBox="1"/>
-          <p:nvPr/>
-        </p:nvSpPr>
-        <p:spPr>
-          <a:xfrm>
-            <a:off x="7040880" y="3035808"/>
+          </a:p>
+        </p:txBody>
+      </p:sp>
+      <p:sp>
+        <p:nvSpPr>
+          <p:cNvPr id="16" name="Text 13"/>
+          <p:cNvSpPr txBox="1"/>
+          <p:nvPr/>
+        </p:nvSpPr>
+        <p:spPr>
+          <a:xfrm>
+            <a:off x="6990080" y="3125216"/>
             <a:ext cx="4572000" cy="868680"/>
           </a:xfrm>
           <a:prstGeom prst="rect">
@@ -8080,7 +8219,7 @@
                 <a:ea typeface="Calibri" pitchFamily="34" charset="-122"/>
                 <a:cs typeface="Calibri" pitchFamily="34" charset="-120"/>
               </a:rPr>
-              <a:t>Calibrate impact with event studies on real returns instead of a hand-tuned scale.</a:t>
+              <a:t>Move from linear scaling to factor or historical-simulation shocks; add capital and liquidity metrics.</a:t>
             </a:r>
             <a:endParaRPr lang="en-US" sz="1500" dirty="0"/>
           </a:p>
@@ -8088,13 +8227,13 @@
       </p:sp>
       <p:sp>
         <p:nvSpPr>
-          <p:cNvPr id="14" name="Shape 11"/>
+          <p:cNvPr id="17" name="Shape 14"/>
           <p:cNvSpPr/>
           <p:nvPr/>
         </p:nvSpPr>
         <p:spPr>
           <a:xfrm>
-            <a:off x="6400800" y="4096512"/>
+            <a:off x="6350000" y="4185920"/>
             <a:ext cx="457200" cy="457200"/>
           </a:xfrm>
           <a:prstGeom prst="ellipse">
@@ -8113,13 +8252,13 @@
       </p:sp>
       <p:sp>
         <p:nvSpPr>
-          <p:cNvPr id="15" name="Text 12"/>
-          <p:cNvSpPr txBox="1"/>
-          <p:nvPr/>
-        </p:nvSpPr>
-        <p:spPr>
-          <a:xfrm>
-            <a:off x="6400800" y="4096512"/>
+          <p:cNvPr id="18" name="Text 15"/>
+          <p:cNvSpPr txBox="1"/>
+          <p:nvPr/>
+        </p:nvSpPr>
+        <p:spPr>
+          <a:xfrm>
+            <a:off x="6350000" y="4185920"/>
             <a:ext cx="457200" cy="457200"/>
           </a:xfrm>
           <a:prstGeom prst="rect">
@@ -8136,120 +8275,22 @@
               <a:buNone/>
             </a:pPr>
             <a:r>
-              <a:rPr lang="en-US" sz="1700" b="1" dirty="0">
+              <a:rPr lang="en-US" sz="1700" b="1">
                 <a:solidFill>
                   <a:srgbClr val="FFFFFF"/>
                 </a:solidFill>
-                <a:latin typeface="Cambria" pitchFamily="34" charset="0"/>
-                <a:ea typeface="Cambria" pitchFamily="34" charset="-122"/>
-                <a:cs typeface="Cambria" pitchFamily="34" charset="-120"/>
+                <a:latin typeface="Cambria"/>
+                <a:ea typeface="Cambria"/>
               </a:rPr>
               <a:t>3</a:t>
             </a:r>
-            <a:endParaRPr lang="en-US" sz="1700" dirty="0"/>
-          </a:p>
-        </p:txBody>
-      </p:sp>
-      <p:sp>
-        <p:nvSpPr>
-          <p:cNvPr id="16" name="Text 13"/>
-          <p:cNvSpPr txBox="1"/>
-          <p:nvPr/>
-        </p:nvSpPr>
-        <p:spPr>
-          <a:xfrm>
-            <a:off x="7040880" y="4059936"/>
-            <a:ext cx="4572000" cy="868680"/>
-          </a:xfrm>
-          <a:prstGeom prst="rect">
-            <a:avLst/>
-          </a:prstGeom>
-          <a:noFill/>
-          <a:ln/>
-        </p:spPr>
-        <p:txBody>
-          <a:bodyPr wrap="square" lIns="0" tIns="0" rIns="0" bIns="0" rtlCol="0" anchor="t"/>
-          <a:lstStyle/>
-          <a:p>
-            <a:pPr marL="0" indent="0">
-              <a:buNone/>
-            </a:pPr>
-            <a:r>
-              <a:rPr lang="en-US" sz="1500" dirty="0">
-                <a:solidFill>
-                  <a:srgbClr val="DCEBEC"/>
-                </a:solidFill>
-                <a:latin typeface="Calibri" pitchFamily="34" charset="0"/>
-                <a:ea typeface="Calibri" pitchFamily="34" charset="-122"/>
-                <a:cs typeface="Calibri" pitchFamily="34" charset="-120"/>
-              </a:rPr>
-              <a:t>Move from linear scaling to factor or historical-simulation shocks; add capital and liquidity metrics.</a:t>
-            </a:r>
-            <a:endParaRPr lang="en-US" sz="1500" dirty="0"/>
-          </a:p>
-        </p:txBody>
-      </p:sp>
-      <p:sp>
-        <p:nvSpPr>
-          <p:cNvPr id="17" name="Shape 14"/>
-          <p:cNvSpPr/>
-          <p:nvPr/>
-        </p:nvSpPr>
-        <p:spPr>
-          <a:xfrm>
-            <a:off x="6400800" y="5120640"/>
-            <a:ext cx="457200" cy="457200"/>
-          </a:xfrm>
-          <a:prstGeom prst="ellipse">
-            <a:avLst/>
-          </a:prstGeom>
-          <a:solidFill>
-            <a:srgbClr val="0F7C8A"/>
-          </a:solidFill>
-          <a:ln w="12700">
-            <a:solidFill>
-              <a:srgbClr val="0F7C8A"/>
-            </a:solidFill>
-            <a:prstDash val="solid"/>
-          </a:ln>
-        </p:spPr>
-      </p:sp>
-      <p:sp>
-        <p:nvSpPr>
-          <p:cNvPr id="18" name="Text 15"/>
-          <p:cNvSpPr txBox="1"/>
-          <p:nvPr/>
-        </p:nvSpPr>
-        <p:spPr>
-          <a:xfrm>
-            <a:off x="6400800" y="5120640"/>
-            <a:ext cx="457200" cy="457200"/>
-          </a:xfrm>
-          <a:prstGeom prst="rect">
-            <a:avLst/>
-          </a:prstGeom>
-          <a:noFill/>
-          <a:ln/>
-        </p:spPr>
-        <p:txBody>
-          <a:bodyPr wrap="square" lIns="0" tIns="0" rIns="0" bIns="0" rtlCol="0" anchor="ctr"/>
-          <a:lstStyle/>
-          <a:p>
-            <a:pPr marL="0" indent="0" algn="ctr">
-              <a:buNone/>
-            </a:pPr>
-            <a:r>
-              <a:rPr lang="en-US" sz="1700" b="1" dirty="0">
-                <a:solidFill>
-                  <a:srgbClr val="FFFFFF"/>
-                </a:solidFill>
-                <a:latin typeface="Cambria" pitchFamily="34" charset="0"/>
-                <a:ea typeface="Cambria" pitchFamily="34" charset="-122"/>
-                <a:cs typeface="Cambria" pitchFamily="34" charset="-120"/>
-              </a:rPr>
-              <a:t>4</a:t>
-            </a:r>
-            <a:endParaRPr lang="en-US" sz="1700" dirty="0"/>
+            <a:endParaRPr lang="en-US" sz="1700" b="1" dirty="0">
+              <a:solidFill>
+                <a:srgbClr val="FFFFFF"/>
+              </a:solidFill>
+              <a:latin typeface="Cambria"/>
+              <a:ea typeface="Cambria"/>
+            </a:endParaRPr>
           </a:p>
         </p:txBody>
       </p:sp>
@@ -8261,7 +8302,7 @@
         </p:nvSpPr>
         <p:spPr>
           <a:xfrm>
-            <a:off x="7040880" y="5084064"/>
+            <a:off x="6990080" y="4149344"/>
             <a:ext cx="4572000" cy="868680"/>
           </a:xfrm>
           <a:prstGeom prst="rect">

</xml_diff>